<commit_message>
small fixes to slide predlog
</commit_message>
<xml_diff>
--- a/slides/predlogic.pptx
+++ b/slides/predlogic.pptx
@@ -299,7 +299,7 @@
               <a:pPr>
                 <a:defRPr/>
               </a:pPr>
-              <a:t>19-05-2025</a:t>
+              <a:t>18-05-2026</a:t>
             </a:fld>
             <a:endParaRPr lang="nl-NL"/>
           </a:p>
@@ -9691,7 +9691,7 @@
             </a:pPr>
             <a:r>
               <a:rPr lang="en-US" dirty="0"/>
-              <a:t>STV 2024/25</a:t>
+              <a:t>STV 2025/26</a:t>
             </a:r>
           </a:p>
         </p:txBody>
@@ -9880,7 +9880,37 @@
               <a:rPr lang="en-US" sz="3600" dirty="0">
                 <a:sym typeface="Symbol" pitchFamily="18" charset="2"/>
               </a:rPr>
-              <a:t>  : :  a[</a:t>
+              <a:t>  </a:t>
+            </a:r>
+            <a:r>
+              <a:rPr lang="en-US" sz="3600" dirty="0">
+                <a:highlight>
+                  <a:srgbClr val="FFFF00"/>
+                </a:highlight>
+                <a:sym typeface="Symbol" pitchFamily="18" charset="2"/>
+              </a:rPr>
+              <a:t>:</a:t>
+            </a:r>
+            <a:r>
+              <a:rPr lang="en-US" sz="3600" dirty="0">
+                <a:sym typeface="Symbol" pitchFamily="18" charset="2"/>
+              </a:rPr>
+              <a:t> </a:t>
+            </a:r>
+            <a:r>
+              <a:rPr lang="en-US" sz="3600" dirty="0">
+                <a:highlight>
+                  <a:srgbClr val="FFFF00"/>
+                </a:highlight>
+                <a:sym typeface="Symbol" pitchFamily="18" charset="2"/>
+              </a:rPr>
+              <a:t>:</a:t>
+            </a:r>
+            <a:r>
+              <a:rPr lang="en-US" sz="3600" dirty="0">
+                <a:sym typeface="Symbol" pitchFamily="18" charset="2"/>
+              </a:rPr>
+              <a:t>  a[</a:t>
             </a:r>
             <a:r>
               <a:rPr lang="en-US" sz="3600" dirty="0" err="1">
@@ -10826,7 +10856,22 @@
               <a:rPr lang="en-US" sz="3600" dirty="0">
                 <a:sym typeface="Symbol" pitchFamily="18" charset="2"/>
               </a:rPr>
-              <a:t>  :  </a:t>
+              <a:t>  </a:t>
+            </a:r>
+            <a:r>
+              <a:rPr lang="en-US" sz="3600" dirty="0">
+                <a:highlight>
+                  <a:srgbClr val="FFFF00"/>
+                </a:highlight>
+                <a:sym typeface="Symbol" pitchFamily="18" charset="2"/>
+              </a:rPr>
+              <a:t>:</a:t>
+            </a:r>
+            <a:r>
+              <a:rPr lang="en-US" sz="3600" dirty="0">
+                <a:sym typeface="Symbol" pitchFamily="18" charset="2"/>
+              </a:rPr>
+              <a:t>  </a:t>
             </a:r>
             <a:r>
               <a:rPr lang="en-US" sz="3600" b="1" dirty="0">
@@ -10851,9 +10896,18 @@
             </a:r>
             <a:r>
               <a:rPr lang="en-US" sz="3600" dirty="0">
+                <a:highlight>
+                  <a:srgbClr val="FFFF00"/>
+                </a:highlight>
                 <a:sym typeface="Symbol" pitchFamily="18" charset="2"/>
               </a:rPr>
-              <a:t>:  a[</a:t>
+              <a:t>:</a:t>
+            </a:r>
+            <a:r>
+              <a:rPr lang="en-US" sz="3600" dirty="0">
+                <a:sym typeface="Symbol" pitchFamily="18" charset="2"/>
+              </a:rPr>
+              <a:t>  a[</a:t>
             </a:r>
             <a:r>
               <a:rPr lang="en-US" sz="3600" dirty="0" err="1">
@@ -11930,7 +11984,22 @@
               <a:rPr lang="nl-NL" dirty="0">
                 <a:sym typeface="Symbol" pitchFamily="18" charset="2"/>
               </a:rPr>
-              <a:t>i : i&gt;0 : b[i])   </a:t>
+              <a:t>i : i&gt;0 : b[</a:t>
+            </a:r>
+            <a:r>
+              <a:rPr lang="nl-NL" dirty="0">
+                <a:highlight>
+                  <a:srgbClr val="00FFFF"/>
+                </a:highlight>
+                <a:sym typeface="Symbol" pitchFamily="18" charset="2"/>
+              </a:rPr>
+              <a:t> i </a:t>
+            </a:r>
+            <a:r>
+              <a:rPr lang="nl-NL" dirty="0">
+                <a:sym typeface="Symbol" pitchFamily="18" charset="2"/>
+              </a:rPr>
+              <a:t>])   </a:t>
             </a:r>
             <a:r>
               <a:rPr lang="en-US" dirty="0">
@@ -11939,10 +12008,31 @@
               <a:t>/\   b[</a:t>
             </a:r>
             <a:r>
+              <a:rPr lang="en-US" dirty="0">
+                <a:highlight>
+                  <a:srgbClr val="FFFF00"/>
+                </a:highlight>
+                <a:sym typeface="Symbol" pitchFamily="18" charset="2"/>
+              </a:rPr>
+              <a:t> </a:t>
+            </a:r>
+            <a:r>
               <a:rPr lang="en-US" dirty="0" err="1">
+                <a:highlight>
+                  <a:srgbClr val="FFFF00"/>
+                </a:highlight>
                 <a:sym typeface="Symbol" pitchFamily="18" charset="2"/>
               </a:rPr>
               <a:t>i</a:t>
+            </a:r>
+            <a:r>
+              <a:rPr lang="en-US" dirty="0">
+                <a:highlight>
+                  <a:srgbClr val="FFFF00"/>
+                </a:highlight>
+                <a:sym typeface="Symbol" pitchFamily="18" charset="2"/>
+              </a:rPr>
+              <a:t> </a:t>
             </a:r>
             <a:r>
               <a:rPr lang="en-US" dirty="0">
@@ -11967,7 +12057,7 @@
             </a:r>
             <a:r>
               <a:rPr lang="en-US" dirty="0"/>
-              <a:t>variable” e.g. </a:t>
+              <a:t>variable” e.g. blue </a:t>
             </a:r>
             <a:r>
               <a:rPr lang="en-US" dirty="0" err="1"/>
@@ -11990,7 +12080,7 @@
             </a:r>
             <a:r>
               <a:rPr lang="en-US" dirty="0"/>
-              <a:t> variable” e.g. b and the </a:t>
+              <a:t> variable” e.g. b and the yellow </a:t>
             </a:r>
             <a:r>
               <a:rPr lang="en-US" dirty="0" err="1"/>
@@ -11998,7 +12088,7 @@
             </a:r>
             <a:r>
               <a:rPr lang="en-US" dirty="0"/>
-              <a:t> on the left in the above example.</a:t>
+              <a:t> on the right in the above example.</a:t>
             </a:r>
           </a:p>
           <a:p>
@@ -12920,7 +13010,7 @@
             <a:pPr algn="just"/>
             <a:r>
               <a:rPr lang="en-US" sz="2400" dirty="0"/>
-              <a:t>To improve training, we deliberately make the format more explicit and also more verbose. </a:t>
+              <a:t>To improve training, we deliberately make the format more explicit/verbose. </a:t>
             </a:r>
           </a:p>
           <a:p>
@@ -22855,7 +22945,7 @@
           </a:effectLst>
           <a:extLst>
             <a:ext uri="{C572A759-6A51-4108-AA02-DFA0A04FC94B}">
-              <ma14:wrappingTextBoxFlag xmlns="" xmlns:m="http://schemas.openxmlformats.org/officeDocument/2006/math" xmlns:a14="http://schemas.microsoft.com/office/drawing/2010/main" xmlns:ma14="http://schemas.microsoft.com/office/mac/drawingml/2011/main" val="1"/>
+              <ma14:wrappingTextBoxFlag xmlns:ma14="http://schemas.microsoft.com/office/mac/drawingml/2011/main" xmlns:a14="http://schemas.microsoft.com/office/drawing/2010/main" xmlns:m="http://schemas.openxmlformats.org/officeDocument/2006/math" xmlns="" val="1"/>
             </a:ext>
           </a:extLst>
         </p:spPr>
@@ -23952,7 +24042,7 @@
           </a:ln>
           <a:extLst>
             <a:ext uri="{C572A759-6A51-4108-AA02-DFA0A04FC94B}">
-              <ma14:wrappingTextBoxFlag xmlns="" xmlns:m="http://schemas.openxmlformats.org/officeDocument/2006/math" xmlns:a14="http://schemas.microsoft.com/office/drawing/2010/main" xmlns:ma14="http://schemas.microsoft.com/office/mac/drawingml/2011/main" val="1"/>
+              <ma14:wrappingTextBoxFlag xmlns:ma14="http://schemas.microsoft.com/office/mac/drawingml/2011/main" xmlns:a14="http://schemas.microsoft.com/office/drawing/2010/main" xmlns:m="http://schemas.openxmlformats.org/officeDocument/2006/math" xmlns="" val="1"/>
             </a:ext>
           </a:extLst>
         </p:spPr>
@@ -24293,7 +24383,7 @@
           </a:ln>
           <a:extLst>
             <a:ext uri="{C572A759-6A51-4108-AA02-DFA0A04FC94B}">
-              <ma14:wrappingTextBoxFlag xmlns="" xmlns:m="http://schemas.openxmlformats.org/officeDocument/2006/math" xmlns:a14="http://schemas.microsoft.com/office/drawing/2010/main" xmlns:ma14="http://schemas.microsoft.com/office/mac/drawingml/2011/main" val="1"/>
+              <ma14:wrappingTextBoxFlag xmlns:ma14="http://schemas.microsoft.com/office/mac/drawingml/2011/main" xmlns:a14="http://schemas.microsoft.com/office/drawing/2010/main" xmlns:m="http://schemas.openxmlformats.org/officeDocument/2006/math" xmlns="" val="1"/>
             </a:ext>
           </a:extLst>
         </p:spPr>
@@ -24981,7 +25071,7 @@
           </a:ln>
           <a:extLst>
             <a:ext uri="{C572A759-6A51-4108-AA02-DFA0A04FC94B}">
-              <ma14:wrappingTextBoxFlag xmlns="" xmlns:m="http://schemas.openxmlformats.org/officeDocument/2006/math" xmlns:a14="http://schemas.microsoft.com/office/drawing/2010/main" xmlns:ma14="http://schemas.microsoft.com/office/mac/drawingml/2011/main" val="1"/>
+              <ma14:wrappingTextBoxFlag xmlns:ma14="http://schemas.microsoft.com/office/mac/drawingml/2011/main" xmlns:a14="http://schemas.microsoft.com/office/drawing/2010/main" xmlns:m="http://schemas.openxmlformats.org/officeDocument/2006/math" xmlns="" val="1"/>
             </a:ext>
           </a:extLst>
         </p:spPr>
@@ -26071,7 +26161,7 @@
           </a:effectLst>
           <a:extLst>
             <a:ext uri="{C572A759-6A51-4108-AA02-DFA0A04FC94B}">
-              <ma14:wrappingTextBoxFlag xmlns="" xmlns:m="http://schemas.openxmlformats.org/officeDocument/2006/math" xmlns:a14="http://schemas.microsoft.com/office/drawing/2010/main" xmlns:ma14="http://schemas.microsoft.com/office/mac/drawingml/2011/main" val="1"/>
+              <ma14:wrappingTextBoxFlag xmlns:ma14="http://schemas.microsoft.com/office/mac/drawingml/2011/main" xmlns:a14="http://schemas.microsoft.com/office/drawing/2010/main" xmlns:m="http://schemas.openxmlformats.org/officeDocument/2006/math" xmlns="" val="1"/>
             </a:ext>
           </a:extLst>
         </p:spPr>
@@ -35843,23 +35933,43 @@
           <a:p>
             <a:pPr lvl="1" eaLnBrk="1" hangingPunct="1"/>
             <a:r>
-              <a:rPr lang="en-US" sz="2800" dirty="0"/>
+              <a:rPr lang="en-US" sz="2800" dirty="0">
+                <a:highlight>
+                  <a:srgbClr val="FFFF00"/>
+                </a:highlight>
+              </a:rPr>
               <a:t>Arrays </a:t>
             </a:r>
             <a:r>
-              <a:rPr lang="en-US" sz="2800" dirty="0" err="1"/>
+              <a:rPr lang="en-US" sz="2800" dirty="0" err="1">
+                <a:highlight>
+                  <a:srgbClr val="FFFF00"/>
+                </a:highlight>
+              </a:rPr>
               <a:t>e.g</a:t>
             </a:r>
             <a:r>
-              <a:rPr lang="en-US" sz="2800" dirty="0"/>
+              <a:rPr lang="en-US" sz="2800" dirty="0">
+                <a:highlight>
+                  <a:srgbClr val="FFFF00"/>
+                </a:highlight>
+              </a:rPr>
               <a:t> a[</a:t>
             </a:r>
             <a:r>
-              <a:rPr lang="en-US" sz="2800" dirty="0" err="1"/>
+              <a:rPr lang="en-US" sz="2800" dirty="0" err="1">
+                <a:highlight>
+                  <a:srgbClr val="FFFF00"/>
+                </a:highlight>
+              </a:rPr>
               <a:t>i</a:t>
             </a:r>
             <a:r>
-              <a:rPr lang="en-US" sz="2800" dirty="0"/>
+              <a:rPr lang="en-US" sz="2800" dirty="0">
+                <a:highlight>
+                  <a:srgbClr val="FFFF00"/>
+                </a:highlight>
+              </a:rPr>
               <a:t>]</a:t>
             </a:r>
           </a:p>

</xml_diff>

<commit_message>
small update to predlog slides
</commit_message>
<xml_diff>
--- a/slides/predlogic.pptx
+++ b/slides/predlogic.pptx
@@ -202,6 +202,35 @@
 </p:presentation>
 </file>
 
+<file path=ppt/ink/ink1.xml><?xml version="1.0" encoding="utf-8"?>
+<inkml:ink xmlns:inkml="http://www.w3.org/2003/InkML">
+  <inkml:definitions>
+    <inkml:context xml:id="ctx0">
+      <inkml:inkSource xml:id="inkSrc0">
+        <inkml:traceFormat>
+          <inkml:channel name="X" type="integer" min="-2.14748E9" max="2.14748E9" units="cm"/>
+          <inkml:channel name="Y" type="integer" min="-2.14748E9" max="2.14748E9" units="cm"/>
+          <inkml:channel name="F" type="integer" max="32767" units="dev"/>
+        </inkml:traceFormat>
+        <inkml:channelProperties>
+          <inkml:channelProperty channel="X" name="resolution" value="1000" units="1/cm"/>
+          <inkml:channelProperty channel="Y" name="resolution" value="1000" units="1/cm"/>
+          <inkml:channelProperty channel="F" name="resolution" value="0" units="1/dev"/>
+        </inkml:channelProperties>
+      </inkml:inkSource>
+      <inkml:timestamp xml:id="ts0" timeString="2026-05-21T07:27:27.315"/>
+    </inkml:context>
+    <inkml:brush xml:id="br0">
+      <inkml:brushProperty name="width" value="0.05292" units="cm"/>
+      <inkml:brushProperty name="height" value="0.05292" units="cm"/>
+      <inkml:brushProperty name="color" value="#C00000"/>
+    </inkml:brush>
+  </inkml:definitions>
+  <inkml:trace contextRef="#ctx0" brushRef="#br0">20532 15064 24575,'0'0'0</inkml:trace>
+  <inkml:trace contextRef="#ctx0" brushRef="#br0" timeOffset="2559">4604 10160 24575,'20'0'0,"-5"0"0,-7 0 0,-6 0 0,6 0 0,8 0 0,3 0 0,1 0 0,11 0 0,-11 0 0,15 16 0,0-12 0,1 11 0,-1-15 0,8 0 0,-17 0 0,1 0 0,20 0 0,-22 0 0,1 0 0,-2 0 0,3 0 0,11 0 0,6 0 0,-1 0 0,-8 0 0,-2 0 0,3 0 0,8 0 0,5 0 0,-1 0 0,-5 0-765,8 0 0,-6 0 765,-5 0 0,-1 0-114,0 0 1,0 0 113,-1 0 0,-1 0 0,-3 0 0,2 0 0,1 5 0,2 1 0,-3-1 0,-2-4 0,-1 2 0,10 12 0,4 1 0,-6-12 0,2-5 0,-2 2-1226,8 7 1,-2 0 1225,-9-7 0,2-2 0,-4 1 0,1 1 0,-3-2-33,9-15 33,-10 12 1312,-6-11-1312,9 15 212,-1 0-212,-15 0 1338,9 0 0,4 0-1338,10 0 0,-15-8 0,-1 0 41,12 4-41,-37-12 0,22 16 0,-20 0 0,27 0 0,-11 0 0,4 0 0,3 0 0,1 0 0,-1 0 0,12 0 0,8 0 0,-20 0 0,11 0 0,5 0 0,-24 0 0,13 0 0,-13 0 0,5 0 0,3 0 0,8 0 0,1 0-776,-7 0 1,1 0 775,15 0 0,0 0-263,-16 0 0,-1 0 263,19 0 0,-16 0 0,-15-15 0,-12 11 0,27 4 1508,-27 4-1508,11 11 569,-15 1-569,16-12 0,-12 12 0,12-16 0</inkml:trace>
+</inkml:ink>
+</file>
+
 <file path=ppt/notesMasters/notesMaster1.xml><?xml version="1.0" encoding="utf-8"?>
 <p:notesMaster xmlns:a="http://schemas.openxmlformats.org/drawingml/2006/main" xmlns:r="http://schemas.openxmlformats.org/officeDocument/2006/relationships" xmlns:p="http://schemas.openxmlformats.org/presentationml/2006/main">
   <p:cSld>
@@ -299,7 +328,7 @@
               <a:pPr>
                 <a:defRPr/>
               </a:pPr>
-              <a:t>18-05-2026</a:t>
+              <a:t>20-05-2026</a:t>
             </a:fld>
             <a:endParaRPr lang="nl-NL"/>
           </a:p>
@@ -22945,7 +22974,7 @@
           </a:effectLst>
           <a:extLst>
             <a:ext uri="{C572A759-6A51-4108-AA02-DFA0A04FC94B}">
-              <ma14:wrappingTextBoxFlag xmlns:ma14="http://schemas.microsoft.com/office/mac/drawingml/2011/main" xmlns:a14="http://schemas.microsoft.com/office/drawing/2010/main" xmlns:m="http://schemas.openxmlformats.org/officeDocument/2006/math" xmlns="" val="1"/>
+              <ma14:wrappingTextBoxFlag xmlns="" xmlns:m="http://schemas.openxmlformats.org/officeDocument/2006/math" xmlns:a14="http://schemas.microsoft.com/office/drawing/2010/main" xmlns:ma14="http://schemas.microsoft.com/office/mac/drawingml/2011/main" val="1"/>
             </a:ext>
           </a:extLst>
         </p:spPr>
@@ -24042,7 +24071,7 @@
           </a:ln>
           <a:extLst>
             <a:ext uri="{C572A759-6A51-4108-AA02-DFA0A04FC94B}">
-              <ma14:wrappingTextBoxFlag xmlns:ma14="http://schemas.microsoft.com/office/mac/drawingml/2011/main" xmlns:a14="http://schemas.microsoft.com/office/drawing/2010/main" xmlns:m="http://schemas.openxmlformats.org/officeDocument/2006/math" xmlns="" val="1"/>
+              <ma14:wrappingTextBoxFlag xmlns="" xmlns:m="http://schemas.openxmlformats.org/officeDocument/2006/math" xmlns:a14="http://schemas.microsoft.com/office/drawing/2010/main" xmlns:ma14="http://schemas.microsoft.com/office/mac/drawingml/2011/main" val="1"/>
             </a:ext>
           </a:extLst>
         </p:spPr>
@@ -24383,7 +24412,7 @@
           </a:ln>
           <a:extLst>
             <a:ext uri="{C572A759-6A51-4108-AA02-DFA0A04FC94B}">
-              <ma14:wrappingTextBoxFlag xmlns:ma14="http://schemas.microsoft.com/office/mac/drawingml/2011/main" xmlns:a14="http://schemas.microsoft.com/office/drawing/2010/main" xmlns:m="http://schemas.openxmlformats.org/officeDocument/2006/math" xmlns="" val="1"/>
+              <ma14:wrappingTextBoxFlag xmlns="" xmlns:m="http://schemas.openxmlformats.org/officeDocument/2006/math" xmlns:a14="http://schemas.microsoft.com/office/drawing/2010/main" xmlns:ma14="http://schemas.microsoft.com/office/mac/drawingml/2011/main" val="1"/>
             </a:ext>
           </a:extLst>
         </p:spPr>
@@ -25071,7 +25100,7 @@
           </a:ln>
           <a:extLst>
             <a:ext uri="{C572A759-6A51-4108-AA02-DFA0A04FC94B}">
-              <ma14:wrappingTextBoxFlag xmlns:ma14="http://schemas.microsoft.com/office/mac/drawingml/2011/main" xmlns:a14="http://schemas.microsoft.com/office/drawing/2010/main" xmlns:m="http://schemas.openxmlformats.org/officeDocument/2006/math" xmlns="" val="1"/>
+              <ma14:wrappingTextBoxFlag xmlns="" xmlns:m="http://schemas.openxmlformats.org/officeDocument/2006/math" xmlns:a14="http://schemas.microsoft.com/office/drawing/2010/main" xmlns:ma14="http://schemas.microsoft.com/office/mac/drawingml/2011/main" val="1"/>
             </a:ext>
           </a:extLst>
         </p:spPr>
@@ -26161,7 +26190,7 @@
           </a:effectLst>
           <a:extLst>
             <a:ext uri="{C572A759-6A51-4108-AA02-DFA0A04FC94B}">
-              <ma14:wrappingTextBoxFlag xmlns:ma14="http://schemas.microsoft.com/office/mac/drawingml/2011/main" xmlns:a14="http://schemas.microsoft.com/office/drawing/2010/main" xmlns:m="http://schemas.openxmlformats.org/officeDocument/2006/math" xmlns="" val="1"/>
+              <ma14:wrappingTextBoxFlag xmlns="" xmlns:m="http://schemas.openxmlformats.org/officeDocument/2006/math" xmlns:a14="http://schemas.microsoft.com/office/drawing/2010/main" xmlns:ma14="http://schemas.microsoft.com/office/mac/drawingml/2011/main" val="1"/>
             </a:ext>
           </a:extLst>
         </p:spPr>
@@ -26709,6 +26738,57 @@
           </a:fontRef>
         </p:style>
       </p:cxnSp>
+      <mc:AlternateContent xmlns:mc="http://schemas.openxmlformats.org/markup-compatibility/2006">
+        <mc:Choice xmlns:p14="http://schemas.microsoft.com/office/powerpoint/2010/main" Requires="p14">
+          <p:contentPart p14:bwMode="auto" r:id="rId3">
+            <p14:nvContentPartPr>
+              <p14:cNvPr id="3" name="Ink 2">
+                <a:extLst>
+                  <a:ext uri="{FF2B5EF4-FFF2-40B4-BE49-F238E27FC236}">
+                    <a16:creationId xmlns:a16="http://schemas.microsoft.com/office/drawing/2014/main" id="{36D95A85-7AD1-B994-B86F-2371AC8157C5}"/>
+                  </a:ext>
+                </a:extLst>
+              </p14:cNvPr>
+              <p14:cNvContentPartPr/>
+              <p14:nvPr/>
+            </p14:nvContentPartPr>
+            <p14:xfrm>
+              <a:off x="1657440" y="3657600"/>
+              <a:ext cx="5734440" cy="1765800"/>
+            </p14:xfrm>
+          </p:contentPart>
+        </mc:Choice>
+        <mc:Fallback>
+          <p:pic>
+            <p:nvPicPr>
+              <p:cNvPr id="3" name="Ink 2">
+                <a:extLst>
+                  <a:ext uri="{FF2B5EF4-FFF2-40B4-BE49-F238E27FC236}">
+                    <a16:creationId xmlns:a16="http://schemas.microsoft.com/office/drawing/2014/main" id="{36D95A85-7AD1-B994-B86F-2371AC8157C5}"/>
+                  </a:ext>
+                </a:extLst>
+              </p:cNvPr>
+              <p:cNvPicPr/>
+              <p:nvPr/>
+            </p:nvPicPr>
+            <p:blipFill>
+              <a:blip r:embed="rId4"/>
+              <a:stretch>
+                <a:fillRect/>
+              </a:stretch>
+            </p:blipFill>
+            <p:spPr>
+              <a:xfrm>
+                <a:off x="1648080" y="3648240"/>
+                <a:ext cx="5753160" cy="1784520"/>
+              </a:xfrm>
+              <a:prstGeom prst="rect">
+                <a:avLst/>
+              </a:prstGeom>
+            </p:spPr>
+          </p:pic>
+        </mc:Fallback>
+      </mc:AlternateContent>
     </p:spTree>
   </p:cSld>
   <p:clrMapOvr>
@@ -28633,8 +28713,16 @@
           <a:p>
             <a:pPr lvl="1" eaLnBrk="1" hangingPunct="1"/>
             <a:r>
+              <a:rPr lang="en-US" dirty="0">
+                <a:highlight>
+                  <a:srgbClr val="FFFF00"/>
+                </a:highlight>
+              </a:rPr>
+              <a:t>a[0..n) </a:t>
+            </a:r>
+            <a:r>
               <a:rPr lang="en-US" dirty="0"/>
-              <a:t>a[0..n) : the segment of the array a, starting from index 0 up to but not including n.</a:t>
+              <a:t>: the segment of the array a, starting from index 0 up to but not including n.</a:t>
             </a:r>
           </a:p>
           <a:p>
@@ -30406,7 +30494,7 @@
         <p:spPr bwMode="auto">
           <a:xfrm>
             <a:off x="782936" y="1771223"/>
-            <a:ext cx="7578127" cy="4093428"/>
+            <a:ext cx="7578127" cy="3477875"/>
           </a:xfrm>
           <a:prstGeom prst="rect">
             <a:avLst/>
@@ -30471,7 +30559,7 @@
                   <a:srgbClr val="7030A0"/>
                 </a:solidFill>
               </a:rPr>
-              <a:t>{  enumeration split, </a:t>
+              <a:t>{ split over array, </a:t>
             </a:r>
             <a:r>
               <a:rPr lang="en-US" sz="2000" dirty="0" err="1">
@@ -30487,7 +30575,7 @@
                   <a:srgbClr val="7030A0"/>
                 </a:solidFill>
               </a:rPr>
-              <a:t> A.5.8, justified by A </a:t>
+              <a:t> A.5.15, justified by A </a:t>
             </a:r>
             <a:r>
               <a:rPr lang="en-US" sz="2000" dirty="0">
@@ -30497,60 +30585,6 @@
                 <a:sym typeface="Symbol" pitchFamily="18" charset="2"/>
               </a:rPr>
               <a:t>}</a:t>
-            </a:r>
-          </a:p>
-          <a:p>
-            <a:r>
-              <a:rPr lang="en-US" sz="2000" dirty="0">
-                <a:sym typeface="Symbol" pitchFamily="18" charset="2"/>
-              </a:rPr>
-              <a:t>  </a:t>
-            </a:r>
-            <a:r>
-              <a:rPr lang="en-US" sz="2000" dirty="0"/>
-              <a:t>SUM  (</a:t>
-            </a:r>
-            <a:r>
-              <a:rPr lang="en-US" sz="2000" dirty="0">
-                <a:highlight>
-                  <a:srgbClr val="FFFF00"/>
-                </a:highlight>
-              </a:rPr>
-              <a:t>a</a:t>
-            </a:r>
-            <a:r>
-              <a:rPr lang="en-US" sz="2000" dirty="0"/>
-              <a:t>(   [0..k)  ++ [k]   ))</a:t>
-            </a:r>
-          </a:p>
-          <a:p>
-            <a:r>
-              <a:rPr lang="en-US" sz="2000" dirty="0"/>
-              <a:t>  = </a:t>
-            </a:r>
-            <a:r>
-              <a:rPr lang="en-US" sz="2000" dirty="0">
-                <a:solidFill>
-                  <a:srgbClr val="7030A0"/>
-                </a:solidFill>
-              </a:rPr>
-              <a:t>{  comprehension split </a:t>
-            </a:r>
-            <a:r>
-              <a:rPr lang="en-US" sz="2000" dirty="0" err="1">
-                <a:solidFill>
-                  <a:srgbClr val="7030A0"/>
-                </a:solidFill>
-              </a:rPr>
-              <a:t>Thm</a:t>
-            </a:r>
-            <a:r>
-              <a:rPr lang="en-US" sz="2000" dirty="0">
-                <a:solidFill>
-                  <a:srgbClr val="7030A0"/>
-                </a:solidFill>
-              </a:rPr>
-              <a:t> A.5.12 }</a:t>
             </a:r>
           </a:p>
           <a:p>
@@ -30849,86 +30883,6 @@
                                           <p:spTgt spid="52232">
                                             <p:txEl>
                                               <p:pRg st="8" end="8"/>
-                                            </p:txEl>
-                                          </p:spTgt>
-                                        </p:tgtEl>
-                                        <p:attrNameLst>
-                                          <p:attrName>style.visibility</p:attrName>
-                                        </p:attrNameLst>
-                                      </p:cBhvr>
-                                      <p:to>
-                                        <p:strVal val="visible"/>
-                                      </p:to>
-                                    </p:set>
-                                  </p:childTnLst>
-                                </p:cTn>
-                              </p:par>
-                              <p:par>
-                                <p:cTn id="19" presetID="1" presetClass="entr" presetSubtype="0" fill="hold" nodeType="withEffect">
-                                  <p:stCondLst>
-                                    <p:cond delay="0"/>
-                                  </p:stCondLst>
-                                  <p:childTnLst>
-                                    <p:set>
-                                      <p:cBhvr>
-                                        <p:cTn id="20" dur="1" fill="hold">
-                                          <p:stCondLst>
-                                            <p:cond delay="0"/>
-                                          </p:stCondLst>
-                                        </p:cTn>
-                                        <p:tgtEl>
-                                          <p:spTgt spid="52232">
-                                            <p:txEl>
-                                              <p:pRg st="9" end="9"/>
-                                            </p:txEl>
-                                          </p:spTgt>
-                                        </p:tgtEl>
-                                        <p:attrNameLst>
-                                          <p:attrName>style.visibility</p:attrName>
-                                        </p:attrNameLst>
-                                      </p:cBhvr>
-                                      <p:to>
-                                        <p:strVal val="visible"/>
-                                      </p:to>
-                                    </p:set>
-                                  </p:childTnLst>
-                                </p:cTn>
-                              </p:par>
-                            </p:childTnLst>
-                          </p:cTn>
-                        </p:par>
-                      </p:childTnLst>
-                    </p:cTn>
-                  </p:par>
-                  <p:par>
-                    <p:cTn id="21" fill="hold">
-                      <p:stCondLst>
-                        <p:cond delay="indefinite"/>
-                      </p:stCondLst>
-                      <p:childTnLst>
-                        <p:par>
-                          <p:cTn id="22" fill="hold">
-                            <p:stCondLst>
-                              <p:cond delay="0"/>
-                            </p:stCondLst>
-                            <p:childTnLst>
-                              <p:par>
-                                <p:cTn id="23" presetID="1" presetClass="entr" presetSubtype="0" fill="hold" nodeType="clickEffect">
-                                  <p:stCondLst>
-                                    <p:cond delay="0"/>
-                                  </p:stCondLst>
-                                  <p:childTnLst>
-                                    <p:set>
-                                      <p:cBhvr>
-                                        <p:cTn id="24" dur="1" fill="hold">
-                                          <p:stCondLst>
-                                            <p:cond delay="0"/>
-                                          </p:stCondLst>
-                                        </p:cTn>
-                                        <p:tgtEl>
-                                          <p:spTgt spid="52232">
-                                            <p:txEl>
-                                              <p:pRg st="10" end="10"/>
                                             </p:txEl>
                                           </p:spTgt>
                                         </p:tgtEl>

</xml_diff>